<commit_message>
Implement FLUX-native energy qualification with full unroll and exact resume
</commit_message>
<xml_diff>
--- a/presentations/novel_ppt_approach/Novel_PPT_Approach_VLM_Restoration_Energy.pptx
+++ b/presentations/novel_ppt_approach/Novel_PPT_Approach_VLM_Restoration_Energy.pptx
@@ -3136,7 +3136,7 @@
                 <a:latin typeface="Microsoft YaHei"/>
                 <a:ea typeface="Microsoft YaHei"/>
               </a:rPr>
-              <a:t>2026-10-31 修订草案｜仅 FLUX 可训练主干｜尚未实现/训练，不是已验证结果</a:t>
+              <a:t>2026-10-31 修订草案｜仅 FLUX 可训练主干｜代码已实现，CPU通过；GPU尚未验收</a:t>
             </a:r>
           </a:p>
         </p:txBody>
@@ -3706,7 +3706,7 @@
                 <a:latin typeface="Microsoft YaHei"/>
                 <a:ea typeface="Microsoft YaHei"/>
               </a:rPr>
-              <a:t>2026-10-31 修订草案｜仅 FLUX 可训练主干｜尚未实现/训练，不是已验证结果</a:t>
+              <a:t>2026-10-31 修订草案｜仅 FLUX 可训练主干｜代码已实现，CPU通过；GPU尚未验收</a:t>
             </a:r>
           </a:p>
         </p:txBody>
@@ -4098,7 +4098,7 @@
                 <a:latin typeface="Microsoft YaHei"/>
                 <a:ea typeface="Microsoft YaHei"/>
               </a:rPr>
-              <a:t>状态：FLUX-only 训练器尚未实现，未启动 GPU。</a:t>
+              <a:t>状态：FLUX-only 25步入口已实现，9项CPU测试通过，未启动 GPU。</a:t>
             </a:r>
           </a:p>
           <a:p>
@@ -4115,7 +4115,7 @@
                 <a:latin typeface="Microsoft YaHei"/>
                 <a:ea typeface="Microsoft YaHei"/>
               </a:rPr>
-              <a:t>先按单机4/8张H100/H200兼容目标验收；资源和时长按实测冻结，不暗换配方。</a:t>
+              <a:t>单机4/8张H100/H200；512图、三次更新、全局batch8。显存/速度仍需实测。</a:t>
             </a:r>
           </a:p>
         </p:txBody>
@@ -4293,7 +4293,7 @@
                 <a:latin typeface="Microsoft YaHei"/>
                 <a:ea typeface="Microsoft YaHei"/>
               </a:rPr>
-              <a:t>2026-10-31 修订草案｜仅 FLUX 可训练主干｜尚未实现/训练，不是已验证结果</a:t>
+              <a:t>2026-10-31 修订草案｜仅 FLUX 可训练主干｜代码已实现，CPU通过；GPU尚未验收</a:t>
             </a:r>
           </a:p>
         </p:txBody>
@@ -4880,7 +4880,7 @@
                 <a:latin typeface="Microsoft YaHei"/>
                 <a:ea typeface="Microsoft YaHei"/>
               </a:rPr>
-              <a:t>2026-10-31 修订草案｜仅 FLUX 可训练主干｜尚未实现/训练，不是已验证结果</a:t>
+              <a:t>2026-10-31 修订草案｜仅 FLUX 可训练主干｜代码已实现，CPU通过；GPU尚未验收</a:t>
             </a:r>
           </a:p>
         </p:txBody>
@@ -5467,7 +5467,7 @@
                 <a:latin typeface="Microsoft YaHei"/>
                 <a:ea typeface="Microsoft YaHei"/>
               </a:rPr>
-              <a:t>2026-10-31 修订草案｜仅 FLUX 可训练主干｜尚未实现/训练，不是已验证结果</a:t>
+              <a:t>2026-10-31 修订草案｜仅 FLUX 可训练主干｜代码已实现，CPU通过；GPU尚未验收</a:t>
             </a:r>
           </a:p>
         </p:txBody>
@@ -6037,7 +6037,7 @@
                 <a:latin typeface="Microsoft YaHei"/>
                 <a:ea typeface="Microsoft YaHei"/>
               </a:rPr>
-              <a:t>2026-10-31 修订草案｜仅 FLUX 可训练主干｜尚未实现/训练，不是已验证结果</a:t>
+              <a:t>2026-10-31 修订草案｜仅 FLUX 可训练主干｜代码已实现，CPU通过；GPU尚未验收</a:t>
             </a:r>
           </a:p>
         </p:txBody>
@@ -6928,7 +6928,7 @@
                 <a:latin typeface="Microsoft YaHei"/>
                 <a:ea typeface="Microsoft YaHei"/>
               </a:rPr>
-              <a:t>2026-10-31 修订草案｜仅 FLUX 可训练主干｜尚未实现/训练，不是已验证结果</a:t>
+              <a:t>2026-10-31 修订草案｜仅 FLUX 可训练主干｜代码已实现，CPU通过；GPU尚未验收</a:t>
             </a:r>
           </a:p>
         </p:txBody>
@@ -7515,7 +7515,7 @@
                 <a:latin typeface="Microsoft YaHei"/>
                 <a:ea typeface="Microsoft YaHei"/>
               </a:rPr>
-              <a:t>2026-10-31 修订草案｜仅 FLUX 可训练主干｜尚未实现/训练，不是已验证结果</a:t>
+              <a:t>2026-10-31 修订草案｜仅 FLUX 可训练主干｜代码已实现，CPU通过；GPU尚未验收</a:t>
             </a:r>
           </a:p>
         </p:txBody>
@@ -8102,7 +8102,7 @@
                 <a:latin typeface="Microsoft YaHei"/>
                 <a:ea typeface="Microsoft YaHei"/>
               </a:rPr>
-              <a:t>2026-10-31 修订草案｜仅 FLUX 可训练主干｜尚未实现/训练，不是已验证结果</a:t>
+              <a:t>2026-10-31 修订草案｜仅 FLUX 可训练主干｜代码已实现，CPU通过；GPU尚未验收</a:t>
             </a:r>
           </a:p>
         </p:txBody>
@@ -8690,7 +8690,7 @@
                 <a:latin typeface="Microsoft YaHei"/>
                 <a:ea typeface="Microsoft YaHei"/>
               </a:rPr>
-              <a:t>2026-10-31 修订草案｜仅 FLUX 可训练主干｜尚未实现/训练，不是已验证结果</a:t>
+              <a:t>2026-10-31 修订草案｜仅 FLUX 可训练主干｜代码已实现，CPU通过；GPU尚未验收</a:t>
             </a:r>
           </a:p>
         </p:txBody>

</xml_diff>

<commit_message>
Default GPU experiments to 3x2 and support six-rank FLUX energy training
</commit_message>
<xml_diff>
--- a/presentations/novel_ppt_approach/Novel_PPT_Approach_VLM_Restoration_Energy.pptx
+++ b/presentations/novel_ppt_approach/Novel_PPT_Approach_VLM_Restoration_Energy.pptx
@@ -4098,7 +4098,7 @@
                 <a:latin typeface="Microsoft YaHei"/>
                 <a:ea typeface="Microsoft YaHei"/>
               </a:rPr>
-              <a:t>状态：FLUX-only 25步入口已实现，9项CPU测试通过，未启动 GPU。</a:t>
+              <a:t>状态：FLUX-only 25步入口已实现，16项CPU测试通过，未启动 GPU。</a:t>
             </a:r>
           </a:p>
           <a:p>
@@ -4115,7 +4115,7 @@
                 <a:latin typeface="Microsoft YaHei"/>
                 <a:ea typeface="Microsoft YaHei"/>
               </a:rPr>
-              <a:t>单机4/8张H100/H200；512图、三次更新、全局batch8。显存/速度仍需实测。</a:t>
+              <a:t>默认3节点×2张H100/H200；512图、三次更新、全局batch8。GPU性能待实测。</a:t>
             </a:r>
           </a:p>
         </p:txBody>

</xml_diff>